<commit_message>
imporve the poweproint presentation
</commit_message>
<xml_diff>
--- a/SelfHelp-2026-e.pptx
+++ b/SelfHelp-2026-e.pptx
@@ -217,13 +217,33 @@
           <a:lstStyle/>
           <a:p>
             <a:r>
-              <a:t>Some of you may remember that we presented SelfHelp here in 2021. Today I want to build on that and show how much the platform has changed since then.</a:t>
-            </a:r>
-          </a:p>
-          <a:p/>
-          <a:p>
-            <a:r>
-              <a:t>The main message is simple. SelfHelp is no longer just a website system. It has grown into a platform for complete digital programs.</a:t>
+              <a:rPr dirty="0"/>
+              <a:t>Some of you may remember that we presented </a:t>
+            </a:r>
+            <a:r>
+              <a:rPr dirty="0" err="1"/>
+              <a:t>SelfHelp</a:t>
+            </a:r>
+            <a:r>
+              <a:rPr dirty="0"/>
+              <a:t> here in 2021. Today I want to build on that and show how much the platform has changed since then.</a:t>
+            </a:r>
+          </a:p>
+          <a:p>
+            <a:endParaRPr dirty="0"/>
+          </a:p>
+          <a:p>
+            <a:r>
+              <a:rPr dirty="0"/>
+              <a:t>The main message is simple. </a:t>
+            </a:r>
+            <a:r>
+              <a:rPr dirty="0" err="1"/>
+              <a:t>SelfHelp</a:t>
+            </a:r>
+            <a:r>
+              <a:rPr dirty="0"/>
+              <a:t> is no longer just a website system. It has grown into a platform for complete digital programs.</a:t>
             </a:r>
           </a:p>
         </p:txBody>
@@ -293,25 +313,85 @@
           <a:lstStyle/>
           <a:p>
             <a:r>
-              <a:t>It is also useful to compare SelfHelp with other open and self-hosted tools.</a:t>
-            </a:r>
-          </a:p>
-          <a:p/>
-          <a:p>
-            <a:r>
-              <a:t>LimeSurvey is very strong for surveys. JATOS and formr are strong for online studies. Moodle is strong for learning delivery.</a:t>
-            </a:r>
-          </a:p>
-          <a:p/>
-          <a:p>
-            <a:r>
-              <a:t>SelfHelp is strongest in a different kind of case. It becomes most valuable when content, data collection, workflows, mobile use, permissions, and AI all need to stay connected in one locally controlled system.</a:t>
-            </a:r>
-          </a:p>
-          <a:p/>
-          <a:p>
-            <a:r>
-              <a:t>So the point is not that it replaces every other tool. The point is that it connects more of the full program in one place.</a:t>
+              <a:rPr lang="en-US" dirty="0"/>
+              <a:t>It’s also helpful to look at how </a:t>
+            </a:r>
+            <a:r>
+              <a:rPr lang="en-US" dirty="0" err="1"/>
+              <a:t>SelfHelp</a:t>
+            </a:r>
+            <a:r>
+              <a:rPr lang="en-US" dirty="0"/>
+              <a:t> compares to other tools.</a:t>
+            </a:r>
+          </a:p>
+          <a:p>
+            <a:endParaRPr lang="en-US" dirty="0"/>
+          </a:p>
+          <a:p>
+            <a:r>
+              <a:rPr lang="en-US" dirty="0"/>
+              <a:t>Tools like </a:t>
+            </a:r>
+            <a:r>
+              <a:rPr lang="en-US" dirty="0" err="1"/>
+              <a:t>LimeSurvey</a:t>
+            </a:r>
+            <a:r>
+              <a:rPr lang="en-US" dirty="0"/>
+              <a:t> are very strong when it comes to surveys. JATOS or </a:t>
+            </a:r>
+            <a:r>
+              <a:rPr lang="en-US" dirty="0" err="1"/>
+              <a:t>formr</a:t>
+            </a:r>
+            <a:r>
+              <a:rPr lang="en-US" dirty="0"/>
+              <a:t> are great for running online studies. And Moodle is strong for learning delivery.</a:t>
+            </a:r>
+          </a:p>
+          <a:p>
+            <a:endParaRPr lang="en-US" dirty="0"/>
+          </a:p>
+          <a:p>
+            <a:r>
+              <a:rPr lang="en-US" dirty="0"/>
+              <a:t>But </a:t>
+            </a:r>
+            <a:r>
+              <a:rPr lang="en-US" dirty="0" err="1"/>
+              <a:t>SelfHelp</a:t>
+            </a:r>
+            <a:r>
+              <a:rPr lang="en-US" dirty="0"/>
+              <a:t> is strongest in a slightly different kind of use case.</a:t>
+            </a:r>
+          </a:p>
+          <a:p>
+            <a:endParaRPr lang="en-US" dirty="0"/>
+          </a:p>
+          <a:p>
+            <a:r>
+              <a:rPr lang="en-US" dirty="0"/>
+              <a:t>It really becomes valuable when everything needs to work together—content, data collection, workflows, mobile use, permissions, and AI—all in one locally controlled system.</a:t>
+            </a:r>
+          </a:p>
+          <a:p>
+            <a:endParaRPr lang="en-US" dirty="0"/>
+          </a:p>
+          <a:p>
+            <a:r>
+              <a:rPr lang="en-US" dirty="0"/>
+              <a:t>So the goal isn’t to replace every other tool.</a:t>
+            </a:r>
+          </a:p>
+          <a:p>
+            <a:endParaRPr lang="en-US" dirty="0"/>
+          </a:p>
+          <a:p>
+            <a:r>
+              <a:rPr lang="en-US" dirty="0"/>
+              <a:t>The goal is to bring more of the full program into one place, and keep it connected.</a:t>
             </a:r>
           </a:p>
         </p:txBody>
@@ -381,37 +461,73 @@
           <a:lstStyle/>
           <a:p>
             <a:r>
+              <a:rPr dirty="0"/>
               <a:t>To close, I would summarize it like this.</a:t>
             </a:r>
           </a:p>
-          <a:p/>
-          <a:p>
-            <a:r>
-              <a:t>SelfHelp gives us one platform where content, assessments, workflows, mobile interaction, and AI can all be part of the same program. That is already useful today.</a:t>
-            </a:r>
-          </a:p>
-          <a:p/>
-          <a:p>
-            <a:r>
-              <a:t>At the same time, SelfHelp 2 is already well underway. It is not just a redesign. The goal is to make the platform more structured, easier to extend, and faster to build with.</a:t>
-            </a:r>
-          </a:p>
-          <a:p/>
-          <a:p>
-            <a:r>
-              <a:t>One especially promising next step is LLM-supported content creation. That could reduce the time spent building website structure by hand and give teams more time for the actual study design, content quality, and assessment logic.</a:t>
-            </a:r>
-          </a:p>
-          <a:p/>
-          <a:p>
-            <a:r>
+          <a:p>
+            <a:endParaRPr dirty="0"/>
+          </a:p>
+          <a:p>
+            <a:r>
+              <a:rPr dirty="0" err="1"/>
+              <a:t>SelfHelp</a:t>
+            </a:r>
+            <a:r>
+              <a:rPr dirty="0"/>
+              <a:t> gives us one platform where content, assessments, workflows, mobile interaction, and AI can all be part of the same program. That is already useful today.</a:t>
+            </a:r>
+          </a:p>
+          <a:p>
+            <a:endParaRPr dirty="0"/>
+          </a:p>
+          <a:p>
+            <a:r>
+              <a:rPr dirty="0"/>
+              <a:t>At the same time, </a:t>
+            </a:r>
+            <a:r>
+              <a:rPr dirty="0" err="1"/>
+              <a:t>SelfHelp</a:t>
+            </a:r>
+            <a:r>
+              <a:rPr dirty="0"/>
+              <a:t> 2 is already well underway. It is not just a redesign. The goal is to make the platform more structured, easier to extend, and faster to build with.</a:t>
+            </a:r>
+          </a:p>
+          <a:p>
+            <a:endParaRPr dirty="0"/>
+          </a:p>
+          <a:p>
+            <a:r>
+              <a:rPr lang="en-US" dirty="0"/>
+              <a:t>One especially promising next step is AI-supported content creation. That could reduce the time spent building structures manually, and let teams focus more on study design and content quality.</a:t>
+            </a:r>
+          </a:p>
+          <a:p>
+            <a:endParaRPr dirty="0"/>
+          </a:p>
+          <a:p>
+            <a:r>
+              <a:rPr dirty="0"/>
               <a:t>And if you see value in this direction, especially in the local university AI infrastructure behind it, I would really encourage you to support ID with a short letter of support so that this local LLM service can become a permanent university service.</a:t>
             </a:r>
           </a:p>
-          <a:p/>
-          <a:p>
-            <a:r>
-              <a:t>The main message I would leave you with is this: SelfHelp moves us from isolated digital tools to continuous digital programs.</a:t>
+          <a:p>
+            <a:endParaRPr dirty="0"/>
+          </a:p>
+          <a:p>
+            <a:r>
+              <a:rPr dirty="0"/>
+              <a:t>The main message I would leave you with is this: </a:t>
+            </a:r>
+            <a:r>
+              <a:rPr dirty="0" err="1"/>
+              <a:t>SelfHelp</a:t>
+            </a:r>
+            <a:r>
+              <a:rPr dirty="0"/>
+              <a:t> moves us from isolated digital tools to continuous digital programs.</a:t>
             </a:r>
           </a:p>
         </p:txBody>
@@ -551,20 +667,50 @@
           <a:lstStyle/>
           <a:p>
             <a:r>
-              <a:t>If I had to explain SelfHelp in one sentence, I would call it a platform for running digital programs.</a:t>
-            </a:r>
-          </a:p>
-          <a:p/>
-          <a:p>
-            <a:r>
-              <a:t>What makes it useful is that it brings together pieces that are often separate. Content, assessments, workflows, and mobile delivery can all live in the same system.</a:t>
-            </a:r>
-          </a:p>
-          <a:p/>
-          <a:p>
-            <a:r>
-              <a:t>That makes projects easier to build, easier to adapt, and easier to manage over time. And because it can run under university control, it also fits settings where governance and data protection matter.</a:t>
-            </a:r>
+              <a:rPr lang="en-US" dirty="0"/>
+              <a:t>If I had to describe </a:t>
+            </a:r>
+            <a:r>
+              <a:rPr lang="en-US" dirty="0" err="1"/>
+              <a:t>SelfHelp</a:t>
+            </a:r>
+            <a:r>
+              <a:rPr lang="en-US" dirty="0"/>
+              <a:t> in one sentence, I’d say it’s a platform for running digital programs.</a:t>
+            </a:r>
+          </a:p>
+          <a:p>
+            <a:endParaRPr dirty="0"/>
+          </a:p>
+          <a:p>
+            <a:r>
+              <a:rPr lang="en-US" dirty="0"/>
+              <a:t>What makes it really useful is that it brings everything together in one place. So instead of dealing with separate tools, your content, assessments, workflows, and even mobile delivery all live in the same system.</a:t>
+            </a:r>
+          </a:p>
+          <a:p>
+            <a:endParaRPr dirty="0"/>
+          </a:p>
+          <a:p>
+            <a:r>
+              <a:rPr lang="en-US" dirty="0"/>
+              <a:t>That means it’s much easier to build projects, adjust them when things change, and manage them over time.</a:t>
+            </a:r>
+          </a:p>
+          <a:p>
+            <a:endParaRPr lang="en-US" dirty="0"/>
+          </a:p>
+          <a:p>
+            <a:r>
+              <a:rPr lang="en-US" dirty="0"/>
+              <a:t>And because it can run under university control, it also works really well in environments where governance and data protection are important.</a:t>
+            </a:r>
+          </a:p>
+          <a:p>
+            <a:endParaRPr lang="en-US" dirty="0"/>
+          </a:p>
+          <a:p>
+            <a:endParaRPr dirty="0"/>
           </a:p>
         </p:txBody>
       </p:sp>
@@ -633,26 +779,71 @@
           <a:lstStyle/>
           <a:p>
             <a:r>
-              <a:t>The easiest way to understand the evolution is to look at what changed at each stage.</a:t>
-            </a:r>
-          </a:p>
-          <a:p/>
-          <a:p>
-            <a:r>
-              <a:t>In 2021, SelfHelp was mainly presented as a platform for self-help and research websites. By 2023, it had become more modular and more practical to run, with better page structure, scheduling, and mobile integration.</a:t>
-            </a:r>
-          </a:p>
-          <a:p/>
-          <a:p>
-            <a:r>
-              <a:t>Then from 2024 to 2026, a lot of the progress happened underneath the surface. The data model became stronger, workflows became more systematic, permissions became clearer, and two-factor authentication was added.</a:t>
-            </a:r>
-          </a:p>
-          <a:p/>
-          <a:p>
-            <a:r>
-              <a:t>Once that base became stronger, it made sense to add AI in a more serious way. So the direction is clear. SelfHelp started as a content platform, and it is now growing into a platform for structured digital programs.</a:t>
-            </a:r>
+              <a:rPr lang="en-US" dirty="0"/>
+              <a:t>The easiest way to understand how </a:t>
+            </a:r>
+            <a:r>
+              <a:rPr lang="en-US" dirty="0" err="1"/>
+              <a:t>SelfHelp</a:t>
+            </a:r>
+            <a:r>
+              <a:rPr lang="en-US" dirty="0"/>
+              <a:t> evolved is to look at what changed over time.</a:t>
+            </a:r>
+          </a:p>
+          <a:p>
+            <a:endParaRPr dirty="0"/>
+          </a:p>
+          <a:p>
+            <a:r>
+              <a:rPr lang="en-US" dirty="0"/>
+              <a:t>In the beginning, around 2021, it was mainly used for self-help and research websites, so the focus was really on publishing content.</a:t>
+            </a:r>
+          </a:p>
+          <a:p>
+            <a:endParaRPr lang="en-US" dirty="0"/>
+          </a:p>
+          <a:p>
+            <a:r>
+              <a:rPr lang="en-US" dirty="0"/>
+              <a:t>By 2023, it became more modular and more practical to run. Things like better page structures, scheduling, and mobile integration were added.</a:t>
+            </a:r>
+          </a:p>
+          <a:p>
+            <a:endParaRPr dirty="0"/>
+          </a:p>
+          <a:p>
+            <a:r>
+              <a:rPr lang="en-US" dirty="0"/>
+              <a:t>Then from 2024 to 2026, a lot of the improvements happened behind the scenes. The data model got stronger, workflows became more structured, permissions clearer, and features like two-factor authentication were introduced.</a:t>
+            </a:r>
+          </a:p>
+          <a:p>
+            <a:endParaRPr dirty="0"/>
+          </a:p>
+          <a:p>
+            <a:r>
+              <a:rPr lang="en-US" dirty="0"/>
+              <a:t>And once that foundation was in place, it made sense to bring in AI in a more meaningful way. </a:t>
+            </a:r>
+          </a:p>
+          <a:p>
+            <a:endParaRPr lang="en-US" dirty="0"/>
+          </a:p>
+          <a:p>
+            <a:r>
+              <a:rPr lang="en-US" dirty="0"/>
+              <a:t>So overall, you can see the direction: </a:t>
+            </a:r>
+            <a:r>
+              <a:rPr lang="en-US" dirty="0" err="1"/>
+              <a:t>SelfHelp</a:t>
+            </a:r>
+            <a:r>
+              <a:rPr lang="en-US" dirty="0"/>
+              <a:t> started as a content platform, and is now evolving into a platform for structured digital programs</a:t>
+            </a:r>
+            <a:endParaRPr dirty="0"/>
           </a:p>
         </p:txBody>
       </p:sp>
@@ -721,26 +912,45 @@
           <a:lstStyle/>
           <a:p>
             <a:r>
+              <a:rPr dirty="0"/>
               <a:t>What this means in practice is that a team can take an idea and turn it into a full user journey.</a:t>
             </a:r>
           </a:p>
-          <a:p/>
-          <a:p>
-            <a:r>
-              <a:t>With SelfHelp, you can build a complete digital program: onboarding, content, structured assessments, reminders, and follow-up. That can all happen in one environment instead of being spread across disconnected tools.</a:t>
-            </a:r>
-          </a:p>
-          <a:p/>
-          <a:p>
-            <a:r>
-              <a:t>People can move through the program step by step. The system can adjust content, timing, and next actions based on role, group, language, or what already happened before.</a:t>
-            </a:r>
-          </a:p>
-          <a:p/>
-          <a:p>
-            <a:r>
-              <a:t>So the value is not only that SelfHelp can publish content. It can run a process over time.</a:t>
-            </a:r>
+          <a:p>
+            <a:endParaRPr dirty="0"/>
+          </a:p>
+          <a:p>
+            <a:r>
+              <a:rPr lang="en-US" dirty="0"/>
+              <a:t>With </a:t>
+            </a:r>
+            <a:r>
+              <a:rPr lang="en-US" dirty="0" err="1"/>
+              <a:t>SelfHelp</a:t>
+            </a:r>
+            <a:r>
+              <a:rPr lang="en-US" dirty="0"/>
+              <a:t>, you’re not just creating content—you can build an entire digital program. That includes onboarding, structured assessments, reminders, and follow-up, all in one place instead of across different tools.</a:t>
+            </a:r>
+          </a:p>
+          <a:p>
+            <a:endParaRPr dirty="0"/>
+          </a:p>
+          <a:p>
+            <a:r>
+              <a:rPr lang="en-US" dirty="0"/>
+              <a:t>Users then move through the program step by step. And along the way, the system can adapt—based on their role, their group, their language, or what they’ve already done.</a:t>
+            </a:r>
+          </a:p>
+          <a:p>
+            <a:endParaRPr dirty="0"/>
+          </a:p>
+          <a:p>
+            <a:r>
+              <a:rPr lang="en-US" dirty="0"/>
+              <a:t>So the real value isn’t just publishing content… it’s being able to run a process over time.</a:t>
+            </a:r>
+            <a:endParaRPr dirty="0"/>
           </a:p>
         </p:txBody>
       </p:sp>
@@ -809,26 +1019,45 @@
           <a:lstStyle/>
           <a:p>
             <a:r>
-              <a:t>Another important part of the story is how SelfHelp grows.</a:t>
-            </a:r>
-          </a:p>
-          <a:p/>
-          <a:p>
-            <a:r>
-              <a:t>It grows through plugins. That means new capabilities can be added without rebuilding the core platform every time.</a:t>
-            </a:r>
-          </a:p>
-          <a:p/>
-          <a:p>
-            <a:r>
-              <a:t>Some of those plugins matter mainly in the background. External authentication helps with institutional access. Lab.js brings browser-based experiments into the same environment. R integration supports more advanced analysis. And custom formulas allow scoring and derived values directly in the system.</a:t>
-            </a:r>
-          </a:p>
-          <a:p/>
-          <a:p>
-            <a:r>
-              <a:t>On top of that, there are also newer plugins that are much more visible from the user side. Those are the three I want to show next.</a:t>
-            </a:r>
+              <a:rPr dirty="0"/>
+              <a:t>Another important part of the story is how </a:t>
+            </a:r>
+            <a:r>
+              <a:rPr dirty="0" err="1"/>
+              <a:t>SelfHelp</a:t>
+            </a:r>
+            <a:r>
+              <a:rPr dirty="0"/>
+              <a:t> grows.</a:t>
+            </a:r>
+          </a:p>
+          <a:p>
+            <a:endParaRPr dirty="0"/>
+          </a:p>
+          <a:p>
+            <a:r>
+              <a:rPr lang="en-US" dirty="0"/>
+              <a:t>It expands through plugins. So instead of rebuilding the whole platform every time, you can just add new capabilities when you need them.</a:t>
+            </a:r>
+          </a:p>
+          <a:p>
+            <a:endParaRPr dirty="0"/>
+          </a:p>
+          <a:p>
+            <a:r>
+              <a:rPr lang="en-US" dirty="0"/>
+              <a:t>Some of these plugins work more in the background. For example, external authentication helps with institutional access. Lab.js brings browser-based experiments into the same system. R integration allows more advanced analysis. And custom formulas let you calculate scores and derived values directly inside the platform.</a:t>
+            </a:r>
+          </a:p>
+          <a:p>
+            <a:endParaRPr dirty="0"/>
+          </a:p>
+          <a:p>
+            <a:r>
+              <a:rPr lang="en-US" dirty="0"/>
+              <a:t>And then there are newer plugins that are much more visible to users. Those are the three I want to show you next.</a:t>
+            </a:r>
+            <a:endParaRPr dirty="0"/>
           </a:p>
         </p:txBody>
       </p:sp>
@@ -897,26 +1126,65 @@
           <a:lstStyle/>
           <a:p>
             <a:r>
-              <a:t>SurveyJS is a good example of how SelfHelp has moved beyond simple forms.</a:t>
-            </a:r>
-          </a:p>
-          <a:p/>
-          <a:p>
-            <a:r>
+              <a:rPr dirty="0" err="1"/>
+              <a:t>SurveyJS</a:t>
+            </a:r>
+            <a:r>
+              <a:rPr dirty="0"/>
+              <a:t> is a good example of how </a:t>
+            </a:r>
+            <a:r>
+              <a:rPr dirty="0" err="1"/>
+              <a:t>SelfHelp</a:t>
+            </a:r>
+            <a:r>
+              <a:rPr dirty="0"/>
+              <a:t> has moved beyond simple forms.</a:t>
+            </a:r>
+          </a:p>
+          <a:p>
+            <a:endParaRPr dirty="0"/>
+          </a:p>
+          <a:p>
+            <a:r>
+              <a:rPr dirty="0"/>
               <a:t>The key point is not only that surveys can be created. The key point is that they can be managed properly inside the platform. They can be versioned, scheduled, edited later, and connected to dashboards.</a:t>
             </a:r>
           </a:p>
-          <a:p/>
-          <a:p>
-            <a:r>
-              <a:t>That improves data quality and makes repeated assessment much easier to handle. It also makes the assessment layer more flexible, because responses can include files and voice recordings.</a:t>
-            </a:r>
-          </a:p>
-          <a:p/>
-          <a:p>
-            <a:r>
-              <a:t>So SurveyJS makes SelfHelp a much stronger environment for structured data collection over time.</a:t>
-            </a:r>
+          <a:p>
+            <a:endParaRPr dirty="0"/>
+          </a:p>
+          <a:p>
+            <a:r>
+              <a:rPr lang="en-US" dirty="0"/>
+              <a:t>That makes a big difference for data quality, especially when you’re running repeated assessments over time. It also makes things more flexible, because responses aren’t limited to just text—you can include files or even voice recordings.</a:t>
+            </a:r>
+          </a:p>
+          <a:p>
+            <a:endParaRPr dirty="0"/>
+          </a:p>
+          <a:p>
+            <a:r>
+              <a:rPr lang="en-US" dirty="0"/>
+              <a:t>So overall, </a:t>
+            </a:r>
+            <a:r>
+              <a:rPr lang="en-US" dirty="0" err="1"/>
+              <a:t>SurveyJS</a:t>
+            </a:r>
+            <a:r>
+              <a:rPr lang="en-US" dirty="0"/>
+              <a:t> turns </a:t>
+            </a:r>
+            <a:r>
+              <a:rPr lang="en-US" dirty="0" err="1"/>
+              <a:t>SelfHelp</a:t>
+            </a:r>
+            <a:r>
+              <a:rPr lang="en-US" dirty="0"/>
+              <a:t> into a much stronger environment for structured data collection over time.</a:t>
+            </a:r>
+            <a:endParaRPr dirty="0"/>
           </a:p>
         </p:txBody>
       </p:sp>
@@ -985,25 +1253,53 @@
           <a:lstStyle/>
           <a:p>
             <a:r>
-              <a:t>The LLM plugin should not be understood as just a chatbot. It is better understood as a controlled and testable AI component.</a:t>
-            </a:r>
-          </a:p>
-          <a:p/>
-          <a:p>
-            <a:r>
-              <a:t>It lets us place a purpose-built assistant inside a page, with a clear role and a clear context. A very important part of that is prompt management. Prompts can be versioned, tested, replayed, and improved before they are used in a real setting.</a:t>
-            </a:r>
-          </a:p>
-          <a:p/>
-          <a:p>
-            <a:r>
-              <a:t>The plugin can also work with files, images, and voice input. And it can return either normal conversation or structured JSON output, including formats that fit OpenAI-style workflows.</a:t>
-            </a:r>
-          </a:p>
-          <a:p/>
-          <a:p>
-            <a:r>
-              <a:t>That matters because it makes AI output easier to connect back into the platform in a controlled way. And right now, we are using the university's local LLM infrastructure, which means the interaction stays inside the university environment.</a:t>
+              <a:rPr lang="en-US" dirty="0"/>
+              <a:t>The LLM plugin is not just a chatbot. It’s better understood as a controlled, testable AI component.</a:t>
+            </a:r>
+          </a:p>
+          <a:p>
+            <a:endParaRPr lang="en-US" dirty="0"/>
+          </a:p>
+          <a:p>
+            <a:r>
+              <a:rPr lang="en-US" dirty="0"/>
+              <a:t>What that means is you can place a purpose-built assistant directly inside a page, with a clear role and a clear context.</a:t>
+            </a:r>
+          </a:p>
+          <a:p>
+            <a:endParaRPr lang="en-US" dirty="0"/>
+          </a:p>
+          <a:p>
+            <a:r>
+              <a:rPr lang="en-US" dirty="0"/>
+              <a:t>A big part of this is prompt management. Prompts can be versioned, tested, and improved before they’re actually used in a real setting.</a:t>
+            </a:r>
+          </a:p>
+          <a:p>
+            <a:endParaRPr lang="en-US" dirty="0"/>
+          </a:p>
+          <a:p>
+            <a:r>
+              <a:rPr lang="en-US" dirty="0"/>
+              <a:t>It also supports different types of input—like text, files, images, or even speech.</a:t>
+            </a:r>
+          </a:p>
+          <a:p>
+            <a:endParaRPr lang="en-US" dirty="0"/>
+          </a:p>
+          <a:p>
+            <a:r>
+              <a:rPr lang="en-US" dirty="0"/>
+              <a:t>And on the output side, it’s not limited to just chat. It can return structured data as well, which makes it much easier to integrate AI results back into the platform.</a:t>
+            </a:r>
+          </a:p>
+          <a:p>
+            <a:endParaRPr lang="en-US" dirty="0"/>
+          </a:p>
+          <a:p>
+            <a:r>
+              <a:rPr lang="en-US" dirty="0"/>
+              <a:t>And importantly, everything can run on the university’s local LLM infrastructure—so the data stays within the university environment.</a:t>
             </a:r>
           </a:p>
         </p:txBody>
@@ -1073,25 +1369,44 @@
           <a:lstStyle/>
           <a:p>
             <a:r>
-              <a:t>The therapy chat plugin is probably the most distinctive part of the current platform.</a:t>
-            </a:r>
-          </a:p>
-          <a:p/>
-          <a:p>
-            <a:r>
-              <a:t>The key idea is supervised communication. A user can interact with AI, but therapists remain present through their own dashboard. They can review conversations, step in directly, write notes, generate drafts, and manage risk status.</a:t>
-            </a:r>
-          </a:p>
-          <a:p/>
-          <a:p>
-            <a:r>
-              <a:t>It is also important that this can run without AI. That means the same framework can support both AI-assisted and human-only communication.</a:t>
-            </a:r>
-          </a:p>
-          <a:p/>
-          <a:p>
-            <a:r>
-              <a:t>That makes it interesting not only for service delivery, but also for research, because different communication models can be compared in the same environment.</a:t>
+              <a:rPr lang="en-US" dirty="0"/>
+              <a:t>The therapy chat plugin is probably the most distinctive part of the platform.</a:t>
+            </a:r>
+          </a:p>
+          <a:p>
+            <a:endParaRPr lang="en-US" dirty="0"/>
+          </a:p>
+          <a:p>
+            <a:r>
+              <a:rPr lang="en-US" dirty="0"/>
+              <a:t>The key idea here is supervised communication. A user can interact with AI, but therapists are still actively involved through their own dashboard.</a:t>
+            </a:r>
+          </a:p>
+          <a:p>
+            <a:endParaRPr lang="en-US" dirty="0"/>
+          </a:p>
+          <a:p>
+            <a:r>
+              <a:rPr lang="en-US" dirty="0"/>
+              <a:t>They can review conversations, step in when needed, write notes, create drafts, and manage risk.</a:t>
+            </a:r>
+          </a:p>
+          <a:p>
+            <a:endParaRPr lang="en-US" dirty="0"/>
+          </a:p>
+          <a:p>
+            <a:r>
+              <a:rPr lang="en-US" dirty="0"/>
+              <a:t>Another important point is that this setup can also run without AI. So you can use the same framework for both AI-assisted and fully human communication.</a:t>
+            </a:r>
+          </a:p>
+          <a:p>
+            <a:endParaRPr lang="en-US" dirty="0"/>
+          </a:p>
+          <a:p>
+            <a:r>
+              <a:rPr lang="en-US" dirty="0"/>
+              <a:t>And that’s what makes it interesting—not just for service delivery, but also for research, because you can compare different communication approaches within the same system.</a:t>
             </a:r>
           </a:p>
         </p:txBody>
@@ -1161,25 +1476,52 @@
           <a:lstStyle/>
           <a:p>
             <a:r>
-              <a:t>The mobile app matters because digital programs rarely stay on the desktop.</a:t>
-            </a:r>
-          </a:p>
-          <a:p/>
-          <a:p>
-            <a:r>
-              <a:t>SelfHelp already has a mobile frontend that uses the same platform logic. Surveys, AI chat, therapy chat, notifications, camera input, and microphone input are already part of that picture.</a:t>
-            </a:r>
-          </a:p>
-          <a:p/>
-          <a:p>
-            <a:r>
-              <a:t>That makes repeated interaction much easier in real life. People can respond, upload, reflect, or interact when it fits their day, not only when they are sitting at a computer.</a:t>
-            </a:r>
-          </a:p>
-          <a:p/>
-          <a:p>
-            <a:r>
-              <a:t>So the same program can stay with the user across different situations, instead of being split across separate tools.</a:t>
+              <a:rPr lang="en-US" dirty="0"/>
+              <a:t>The mobile app is important because digital programs don’t just live on a desktop.</a:t>
+            </a:r>
+          </a:p>
+          <a:p>
+            <a:endParaRPr lang="en-US" dirty="0"/>
+          </a:p>
+          <a:p>
+            <a:r>
+              <a:rPr lang="en-US" dirty="0"/>
+              <a:t>With </a:t>
+            </a:r>
+            <a:r>
+              <a:rPr lang="en-US" dirty="0" err="1"/>
+              <a:t>SelfHelp</a:t>
+            </a:r>
+            <a:r>
+              <a:rPr lang="en-US" dirty="0"/>
+              <a:t>, the same program logic continues on mobile—so it becomes part of everyday use, not just something you access occasionally on a computer.</a:t>
+            </a:r>
+          </a:p>
+          <a:p>
+            <a:endParaRPr lang="en-US" dirty="0"/>
+          </a:p>
+          <a:p>
+            <a:r>
+              <a:rPr lang="en-US" dirty="0"/>
+              <a:t>And a lot is already supported: surveys, AI chat, therapy chat, notifications, and even camera and microphone input.</a:t>
+            </a:r>
+          </a:p>
+          <a:p>
+            <a:endParaRPr lang="en-US" dirty="0"/>
+          </a:p>
+          <a:p>
+            <a:r>
+              <a:rPr lang="en-US" dirty="0"/>
+              <a:t>What that means in practice is that people can interact with the program when it fits their day. They can respond, upload something, or continue a conversation—wherever they are.</a:t>
+            </a:r>
+          </a:p>
+          <a:p>
+            <a:endParaRPr lang="en-US" dirty="0"/>
+          </a:p>
+          <a:p>
+            <a:r>
+              <a:rPr lang="en-US" dirty="0"/>
+              <a:t>So instead of being tied to one place, the program stays with the user across different situations.</a:t>
             </a:r>
           </a:p>
         </p:txBody>
@@ -1349,7 +1691,7 @@
           <a:p>
             <a:fld id="{1D8BD707-D9CF-40AE-B4C6-C98DA3205C09}" type="datetimeFigureOut">
               <a:rPr lang="en-US"/>
-              <a:t>24-Mar-26</a:t>
+              <a:t>25-Mar-26</a:t>
             </a:fld>
             <a:endParaRPr lang="en-US"/>
           </a:p>
@@ -1520,7 +1862,7 @@
           <a:p>
             <a:fld id="{1D8BD707-D9CF-40AE-B4C6-C98DA3205C09}" type="datetimeFigureOut">
               <a:rPr lang="en-US"/>
-              <a:t>24-Mar-26</a:t>
+              <a:t>25-Mar-26</a:t>
             </a:fld>
             <a:endParaRPr lang="en-US"/>
           </a:p>
@@ -1740,7 +2082,7 @@
           <a:p>
             <a:fld id="{1D8BD707-D9CF-40AE-B4C6-C98DA3205C09}" type="datetimeFigureOut">
               <a:rPr lang="en-US"/>
-              <a:t>24-Mar-26</a:t>
+              <a:t>25-Mar-26</a:t>
             </a:fld>
             <a:endParaRPr lang="en-US"/>
           </a:p>
@@ -1888,7 +2230,7 @@
           <a:p>
             <a:fld id="{1D8BD707-D9CF-40AE-B4C6-C98DA3205C09}" type="datetimeFigureOut">
               <a:rPr lang="en-US"/>
-              <a:t>24-Mar-26</a:t>
+              <a:t>25-Mar-26</a:t>
             </a:fld>
             <a:endParaRPr lang="en-US"/>
           </a:p>
@@ -2007,7 +2349,7 @@
           <a:p>
             <a:fld id="{1D8BD707-D9CF-40AE-B4C6-C98DA3205C09}" type="datetimeFigureOut">
               <a:rPr lang="en-US"/>
-              <a:t>24-Mar-26</a:t>
+              <a:t>25-Mar-26</a:t>
             </a:fld>
             <a:endParaRPr lang="en-US"/>
           </a:p>
@@ -2226,7 +2568,7 @@
           <a:p>
             <a:fld id="{1D8BD707-D9CF-40AE-B4C6-C98DA3205C09}" type="datetimeFigureOut">
               <a:rPr lang="en-US"/>
-              <a:t>24-Mar-26</a:t>
+              <a:t>25-Mar-26</a:t>
             </a:fld>
             <a:endParaRPr lang="en-US"/>
           </a:p>

</xml_diff>

<commit_message>
change notes on the presnetations
</commit_message>
<xml_diff>
--- a/SelfHelp-2026-e.pptx
+++ b/SelfHelp-2026-e.pptx
@@ -217,8 +217,25 @@
           <a:lstStyle/>
           <a:p>
             <a:r>
+              <a:rPr lang="en-US" dirty="0"/>
+              <a:t>Hallo everyone, for those who does not know me, my name is Stefan Kodzhabashev, I am research software engineer and I work in TPF.</a:t>
+            </a:r>
+          </a:p>
+          <a:p>
+            <a:endParaRPr lang="en-US" dirty="0"/>
+          </a:p>
+          <a:p>
+            <a:r>
               <a:rPr dirty="0"/>
-              <a:t>Some of you may remember that we presented </a:t>
+              <a:t>Some of you may remember that </a:t>
+            </a:r>
+            <a:r>
+              <a:rPr lang="en-US" dirty="0"/>
+              <a:t>I already</a:t>
+            </a:r>
+            <a:r>
+              <a:rPr dirty="0"/>
+              <a:t> presented </a:t>
             </a:r>
             <a:r>
               <a:rPr dirty="0" err="1"/>
@@ -234,8 +251,12 @@
           </a:p>
           <a:p>
             <a:r>
+              <a:rPr lang="en-US" dirty="0"/>
+              <a:t>In short:</a:t>
+            </a:r>
+            <a:r>
               <a:rPr dirty="0"/>
-              <a:t>The main message is simple. </a:t>
+              <a:t> </a:t>
             </a:r>
             <a:r>
               <a:rPr dirty="0" err="1"/>
@@ -461,8 +482,12 @@
           <a:lstStyle/>
           <a:p>
             <a:r>
+              <a:rPr lang="en-US" dirty="0"/>
+              <a:t>At the end</a:t>
+            </a:r>
+            <a:r>
               <a:rPr dirty="0"/>
-              <a:t>To close, I would summarize it like this.</a:t>
+              <a:t> I would summarize it like this.</a:t>
             </a:r>
           </a:p>
           <a:p>
@@ -501,7 +526,7 @@
           <a:p>
             <a:r>
               <a:rPr lang="en-US" dirty="0"/>
-              <a:t>One especially promising next step is AI-supported content creation. That could reduce the time spent building structures manually, and let teams focus more on study design and content quality.</a:t>
+              <a:t>One especially promising next step in the new version is AI-supported content creation. That could reduce the time spent building structures manually, and let teams focus more on study design and content quality.</a:t>
             </a:r>
           </a:p>
           <a:p>
@@ -597,7 +622,11 @@
           <a:lstStyle/>
           <a:p>
             <a:r>
-              <a:t>Thank you very much. I am happy to take questions.</a:t>
+              <a:rPr dirty="0"/>
+              <a:t>Thank you very much. </a:t>
+            </a:r>
+            <a:r>
+              <a:t>I am happy to take questions.</a:t>
             </a:r>
           </a:p>
         </p:txBody>
@@ -1126,8 +1155,16 @@
           <a:lstStyle/>
           <a:p>
             <a:r>
+              <a:rPr lang="en-US" dirty="0"/>
+              <a:t>The first plugin that I want to present is </a:t>
+            </a:r>
+            <a:r>
               <a:rPr dirty="0" err="1"/>
               <a:t>SurveyJS</a:t>
+            </a:r>
+            <a:r>
+              <a:rPr lang="en-US" dirty="0"/>
+              <a:t>. That plugin</a:t>
             </a:r>
             <a:r>
               <a:rPr dirty="0"/>
@@ -1254,7 +1291,7 @@
           <a:p>
             <a:r>
               <a:rPr lang="en-US" dirty="0"/>
-              <a:t>The LLM plugin is not just a chatbot. It’s better understood as a controlled, testable AI component.</a:t>
+              <a:t>The next plugin is  the LLM plugin. I want to point out that this is not just a chatbot. It can be described better as a controlled, testable AI component.</a:t>
             </a:r>
           </a:p>
           <a:p>
@@ -1272,7 +1309,7 @@
           <a:p>
             <a:r>
               <a:rPr lang="en-US" dirty="0"/>
-              <a:t>A big part of this is prompt management. Prompts can be versioned, tested, and improved before they’re actually used in a real setting.</a:t>
+              <a:t>A big part of this is the prompt management system that comes with it. The prompts are the context that we send to the LLMs, they can be versioned, tested, and improved before they’re actually used in a real setting.</a:t>
             </a:r>
           </a:p>
           <a:p>
@@ -1370,7 +1407,7 @@
           <a:p>
             <a:r>
               <a:rPr lang="en-US" dirty="0"/>
-              <a:t>The therapy chat plugin is probably the most distinctive part of the platform.</a:t>
+              <a:t>The last plugin is the therapy chat plugin.</a:t>
             </a:r>
           </a:p>
           <a:p>
@@ -1477,7 +1514,7 @@
           <a:p>
             <a:r>
               <a:rPr lang="en-US" dirty="0"/>
-              <a:t>The mobile app is important because digital programs don’t just live on a desktop.</a:t>
+              <a:t>Another crucial part of the system is the mobile app. It is important because digital programs don’t just live on a desktop.</a:t>
             </a:r>
           </a:p>
           <a:p>
@@ -1503,7 +1540,7 @@
           <a:p>
             <a:r>
               <a:rPr lang="en-US" dirty="0"/>
-              <a:t>And a lot is already supported: surveys, AI chat, therapy chat, notifications, and even camera and microphone input.</a:t>
+              <a:t>All the features that are supported on the web part are already supported on the mobile app too. Like: surveys, AI chat, therapy chat, notifications, and even camera and microphone input.</a:t>
             </a:r>
           </a:p>
           <a:p>
@@ -1512,7 +1549,7 @@
           <a:p>
             <a:r>
               <a:rPr lang="en-US" dirty="0"/>
-              <a:t>What that means in practice is that people can interact with the program when it fits their day. They can respond, upload something, or continue a conversation—wherever they are.</a:t>
+              <a:t>Using a mobile app for your research means in practice, that people (subjects) can interact with the program when it fits their day. They can respond, upload something, or continue a conversation—wherever they are.</a:t>
             </a:r>
           </a:p>
           <a:p>

</xml_diff>

<commit_message>
updated notes for the slefhelp presenation
</commit_message>
<xml_diff>
--- a/SelfHelp-2026-e.pptx
+++ b/SelfHelp-2026-e.pptx
@@ -226,45 +226,34 @@
           </a:p>
           <a:p>
             <a:r>
-              <a:rPr dirty="0"/>
-              <a:t>Some of you may remember that </a:t>
-            </a:r>
-            <a:r>
               <a:rPr lang="en-US" dirty="0"/>
-              <a:t>I already</a:t>
-            </a:r>
-            <a:r>
-              <a:rPr dirty="0"/>
-              <a:t> presented </a:t>
-            </a:r>
-            <a:r>
-              <a:rPr dirty="0" err="1"/>
+              <a:t>Some of you may remember that I already gave a presentation about </a:t>
+            </a:r>
+            <a:r>
+              <a:rPr lang="en-US" dirty="0" err="1"/>
               <a:t>SelfHelp</a:t>
             </a:r>
             <a:r>
-              <a:rPr dirty="0"/>
-              <a:t> here in 2021. Today I want to build on that and show how much the platform has changed since then.</a:t>
-            </a:r>
-          </a:p>
-          <a:p>
-            <a:endParaRPr dirty="0"/>
-          </a:p>
-          <a:p>
-            <a:r>
               <a:rPr lang="en-US" dirty="0"/>
-              <a:t>In short:</a:t>
-            </a:r>
-            <a:r>
-              <a:rPr dirty="0"/>
-              <a:t> </a:t>
-            </a:r>
-            <a:r>
-              <a:rPr dirty="0" err="1"/>
-              <a:t>SelfHelp</a:t>
-            </a:r>
-            <a:r>
-              <a:rPr dirty="0"/>
-              <a:t> is no longer just a website system. It has grown into a platform for complete digital programs.</a:t>
+              <a:t> some years ago, back in 2021.</a:t>
+            </a:r>
+          </a:p>
+          <a:p>
+            <a:endParaRPr lang="en-US" dirty="0"/>
+          </a:p>
+          <a:p>
+            <a:r>
+              <a:rPr lang="en-US" dirty="0"/>
+              <a:t>At that time, the system was still much simpler. It was mainly a website builder. Today, I want to show you how it changed, and what it can do now.</a:t>
+            </a:r>
+          </a:p>
+          <a:p>
+            <a:endParaRPr lang="en-US" dirty="0"/>
+          </a:p>
+          <a:p>
+            <a:r>
+              <a:rPr lang="en-US" dirty="0"/>
+              <a:t>The main idea is not only to build pages. The idea is to connect different digital needs that we have in research, teaching, support, and intervention work, and bring them together in one system.</a:t>
             </a:r>
           </a:p>
         </p:txBody>
@@ -335,7 +324,7 @@
           <a:p>
             <a:r>
               <a:rPr lang="en-US" dirty="0"/>
-              <a:t>It’s also helpful to look at how </a:t>
+              <a:t>If we compare </a:t>
             </a:r>
             <a:r>
               <a:rPr lang="en-US" dirty="0" err="1"/>
@@ -343,7 +332,7 @@
             </a:r>
             <a:r>
               <a:rPr lang="en-US" dirty="0"/>
-              <a:t> compares to other tools.</a:t>
+              <a:t> with other systems, I think it is important to be fair.</a:t>
             </a:r>
           </a:p>
           <a:p>
@@ -352,7 +341,7 @@
           <a:p>
             <a:r>
               <a:rPr lang="en-US" dirty="0"/>
-              <a:t>Tools like </a:t>
+              <a:t>There are strong tools already, like </a:t>
             </a:r>
             <a:r>
               <a:rPr lang="en-US" dirty="0" err="1"/>
@@ -360,7 +349,7 @@
             </a:r>
             <a:r>
               <a:rPr lang="en-US" dirty="0"/>
-              <a:t> are very strong when it comes to surveys. JATOS or </a:t>
+              <a:t>, Moodle, JATOS, or </a:t>
             </a:r>
             <a:r>
               <a:rPr lang="en-US" dirty="0" err="1"/>
@@ -368,7 +357,7 @@
             </a:r>
             <a:r>
               <a:rPr lang="en-US" dirty="0"/>
-              <a:t> are great for running online studies. And Moodle is strong for learning delivery.</a:t>
+              <a:t>. Each of them is good in its own area.</a:t>
             </a:r>
           </a:p>
           <a:p>
@@ -377,7 +366,16 @@
           <a:p>
             <a:r>
               <a:rPr lang="en-US" dirty="0"/>
-              <a:t>But </a:t>
+              <a:t>But usually they focus on one main purpose. One is stronger for surveys, one for online studies, one for learning environments.</a:t>
+            </a:r>
+          </a:p>
+          <a:p>
+            <a:endParaRPr lang="en-US" dirty="0"/>
+          </a:p>
+          <a:p>
+            <a:r>
+              <a:rPr lang="en-US" dirty="0"/>
+              <a:t>What makes </a:t>
             </a:r>
             <a:r>
               <a:rPr lang="en-US" dirty="0" err="1"/>
@@ -385,7 +383,7 @@
             </a:r>
             <a:r>
               <a:rPr lang="en-US" dirty="0"/>
-              <a:t> is strongest in a slightly different kind of use case.</a:t>
+              <a:t> different is the connection between the parts.</a:t>
             </a:r>
           </a:p>
           <a:p>
@@ -394,7 +392,7 @@
           <a:p>
             <a:r>
               <a:rPr lang="en-US" dirty="0"/>
-              <a:t>It really becomes valuable when everything needs to work together—content, data collection, workflows, mobile use, permissions, and AI—all in one locally controlled system.</a:t>
+              <a:t>The strength is not that it replaces every tool in every detail. The strength is that it connects surveys, workflows, follow-up, mobile use, and AI inside one locally controlled environment.</a:t>
             </a:r>
           </a:p>
           <a:p>
@@ -403,16 +401,15 @@
           <a:p>
             <a:r>
               <a:rPr lang="en-US" dirty="0"/>
-              <a:t>So the goal isn’t to replace every other tool.</a:t>
-            </a:r>
-          </a:p>
-          <a:p>
-            <a:endParaRPr lang="en-US" dirty="0"/>
-          </a:p>
-          <a:p>
+              <a:t>So if somebody needs only one very small function, another tool may be enough. But if somebody wants many connected parts in one system, then </a:t>
+            </a:r>
+            <a:r>
+              <a:rPr lang="en-US" dirty="0" err="1"/>
+              <a:t>SelfHelp</a:t>
+            </a:r>
             <a:r>
               <a:rPr lang="en-US" dirty="0"/>
-              <a:t>The goal is to bring more of the full program into one place, and keep it connected.</a:t>
+              <a:t> becomes more interesting.</a:t>
             </a:r>
           </a:p>
         </p:txBody>
@@ -483,24 +480,33 @@
           <a:p>
             <a:r>
               <a:rPr lang="en-US" dirty="0"/>
-              <a:t>At the end</a:t>
-            </a:r>
-            <a:r>
-              <a:rPr dirty="0"/>
-              <a:t> I would summarize it like this.</a:t>
-            </a:r>
-          </a:p>
-          <a:p>
-            <a:endParaRPr dirty="0"/>
-          </a:p>
-          <a:p>
-            <a:r>
-              <a:rPr dirty="0" err="1"/>
+              <a:t>So why use </a:t>
+            </a:r>
+            <a:r>
+              <a:rPr lang="en-US" dirty="0" err="1"/>
               <a:t>SelfHelp</a:t>
             </a:r>
             <a:r>
-              <a:rPr dirty="0"/>
-              <a:t> gives us one platform where content, assessments, workflows, mobile interaction, and AI can all be part of the same program. That is already useful today.</a:t>
+              <a:rPr lang="en-US" dirty="0"/>
+              <a:t>?</a:t>
+            </a:r>
+          </a:p>
+          <a:p>
+            <a:endParaRPr lang="en-US" dirty="0"/>
+          </a:p>
+          <a:p>
+            <a:r>
+              <a:rPr lang="en-US" dirty="0"/>
+              <a:t>I would say the biggest reason is integration.</a:t>
+            </a:r>
+          </a:p>
+          <a:p>
+            <a:endParaRPr lang="en-US" dirty="0"/>
+          </a:p>
+          <a:p>
+            <a:r>
+              <a:rPr lang="en-US" dirty="0"/>
+              <a:t>Instead of splitting everything across many separate tools, you can keep content, data, logic, follow-up, mobile use, and AI in one structure.</a:t>
             </a:r>
           </a:p>
           <a:p>
@@ -622,11 +628,17 @@
           <a:lstStyle/>
           <a:p>
             <a:r>
-              <a:rPr dirty="0"/>
-              <a:t>Thank you very much. </a:t>
-            </a:r>
-            <a:r>
-              <a:t>I am happy to take questions.</a:t>
+              <a:rPr lang="en-US" dirty="0"/>
+              <a:t>Thank you very much for your attention.</a:t>
+            </a:r>
+          </a:p>
+          <a:p>
+            <a:endParaRPr lang="en-US" dirty="0"/>
+          </a:p>
+          <a:p>
+            <a:r>
+              <a:rPr lang="en-US" dirty="0"/>
+              <a:t>I will be happy to answer questions, and also happy to talk afterwards if someone wants to discuss ideas in more detail.</a:t>
             </a:r>
           </a:p>
         </p:txBody>
@@ -697,7 +709,7 @@
           <a:p>
             <a:r>
               <a:rPr lang="en-US" dirty="0"/>
-              <a:t>If I had to describe </a:t>
+              <a:t>So, what is </a:t>
             </a:r>
             <a:r>
               <a:rPr lang="en-US" dirty="0" err="1"/>
@@ -705,25 +717,25 @@
             </a:r>
             <a:r>
               <a:rPr lang="en-US" dirty="0"/>
-              <a:t> in one sentence, I’d say it’s a platform for running digital programs.</a:t>
-            </a:r>
-          </a:p>
-          <a:p>
-            <a:endParaRPr dirty="0"/>
+              <a:t> today?</a:t>
+            </a:r>
+          </a:p>
+          <a:p>
+            <a:endParaRPr lang="en-US" dirty="0"/>
           </a:p>
           <a:p>
             <a:r>
               <a:rPr lang="en-US" dirty="0"/>
-              <a:t>What makes it really useful is that it brings everything together in one place. So instead of dealing with separate tools, your content, assessments, workflows, and even mobile delivery all live in the same system.</a:t>
-            </a:r>
-          </a:p>
-          <a:p>
-            <a:endParaRPr dirty="0"/>
+              <a:t>I would not describe it only as a website tool. For me, it is more a platform that connects different digital problems with practical solutions.</a:t>
+            </a:r>
+          </a:p>
+          <a:p>
+            <a:endParaRPr lang="en-US" dirty="0"/>
           </a:p>
           <a:p>
             <a:r>
               <a:rPr lang="en-US" dirty="0"/>
-              <a:t>That means it’s much easier to build projects, adjust them when things change, and manage them over time.</a:t>
+              <a:t>Very often, in a project, one part is in one system, another part is somewhere else, and communication is in a third place. For example, content is separated from surveys, surveys are separated from follow-up, and data is separated from the actual user journey.</a:t>
             </a:r>
           </a:p>
           <a:p>
@@ -731,8 +743,21 @@
           </a:p>
           <a:p>
             <a:r>
+              <a:rPr lang="en-US" dirty="0" err="1"/>
+              <a:t>SelfHelp</a:t>
+            </a:r>
+            <a:r>
               <a:rPr lang="en-US" dirty="0"/>
-              <a:t>And because it can run under university control, it also works really well in environments where governance and data protection are important.</a:t>
+              <a:t> tries to bring these things together. It connects content, data, workflows, communication, and mobile use in one environment.</a:t>
+            </a:r>
+          </a:p>
+          <a:p>
+            <a:endParaRPr lang="en-US" dirty="0"/>
+          </a:p>
+          <a:p>
+            <a:r>
+              <a:rPr lang="en-US" dirty="0"/>
+              <a:t>This is also important for the university, because the system can run locally, so the university keeps control over the data and how the system is managed.</a:t>
             </a:r>
           </a:p>
           <a:p>
@@ -809,7 +834,7 @@
           <a:p>
             <a:r>
               <a:rPr lang="en-US" dirty="0"/>
-              <a:t>The easiest way to understand how </a:t>
+              <a:t>If we look back to 2021, when I first presented </a:t>
             </a:r>
             <a:r>
               <a:rPr lang="en-US" dirty="0" err="1"/>
@@ -817,16 +842,16 @@
             </a:r>
             <a:r>
               <a:rPr lang="en-US" dirty="0"/>
-              <a:t> evolved is to look at what changed over time.</a:t>
-            </a:r>
-          </a:p>
-          <a:p>
-            <a:endParaRPr dirty="0"/>
+              <a:t>, it was mostly a website builder. The focus was clearly on content and page building.</a:t>
+            </a:r>
+          </a:p>
+          <a:p>
+            <a:endParaRPr lang="en-US" dirty="0"/>
           </a:p>
           <a:p>
             <a:r>
               <a:rPr lang="en-US" dirty="0"/>
-              <a:t>In the beginning, around 2021, it was mainly used for self-help and research websites, so the focus was really on publishing content.</a:t>
+              <a:t>After that, the system slowly became more flexible. We added modular pages, scheduling, and mobile support.</a:t>
             </a:r>
           </a:p>
           <a:p>
@@ -835,44 +860,17 @@
           <a:p>
             <a:r>
               <a:rPr lang="en-US" dirty="0"/>
-              <a:t>By 2023, it became more modular and more practical to run. Things like better page structures, scheduling, and mobile integration were added.</a:t>
-            </a:r>
-          </a:p>
-          <a:p>
-            <a:endParaRPr dirty="0"/>
+              <a:t>Then later, the focus became broader. We improved the data model, permissions, security, background processing, and other things that are important when a system becomes larger and more serious.</a:t>
+            </a:r>
+          </a:p>
+          <a:p>
+            <a:endParaRPr lang="en-US" dirty="0"/>
           </a:p>
           <a:p>
             <a:r>
               <a:rPr lang="en-US" dirty="0"/>
-              <a:t>Then from 2024 to 2026, a lot of the improvements happened behind the scenes. The data model got stronger, workflows became more structured, permissions clearer, and features like two-factor authentication were introduced.</a:t>
-            </a:r>
-          </a:p>
-          <a:p>
-            <a:endParaRPr dirty="0"/>
-          </a:p>
-          <a:p>
-            <a:r>
-              <a:rPr lang="en-US" dirty="0"/>
-              <a:t>And once that foundation was in place, it made sense to bring in AI in a more meaningful way. </a:t>
-            </a:r>
-          </a:p>
-          <a:p>
-            <a:endParaRPr lang="en-US" dirty="0"/>
-          </a:p>
-          <a:p>
-            <a:r>
-              <a:rPr lang="en-US" dirty="0"/>
-              <a:t>So overall, you can see the direction: </a:t>
-            </a:r>
-            <a:r>
-              <a:rPr lang="en-US" dirty="0" err="1"/>
-              <a:t>SelfHelp</a:t>
-            </a:r>
-            <a:r>
-              <a:rPr lang="en-US" dirty="0"/>
-              <a:t> started as a content platform, and is now evolving into a platform for structured digital programs</a:t>
-            </a:r>
-            <a:endParaRPr dirty="0"/>
+              <a:t>And now we are at another step again, because today we also have AI support, but in a controlled and testable way, and not only as a simple chatbot.</a:t>
+            </a:r>
           </a:p>
         </p:txBody>
       </p:sp>
@@ -941,17 +939,35 @@
           <a:lstStyle/>
           <a:p>
             <a:r>
-              <a:rPr dirty="0"/>
-              <a:t>What this means in practice is that a team can take an idea and turn it into a full user journey.</a:t>
-            </a:r>
-          </a:p>
-          <a:p>
-            <a:endParaRPr dirty="0"/>
-          </a:p>
-          <a:p>
-            <a:r>
               <a:rPr lang="en-US" dirty="0"/>
-              <a:t>With </a:t>
+              <a:t>So what can you actually do with it?</a:t>
+            </a:r>
+          </a:p>
+          <a:p>
+            <a:endParaRPr lang="en-US" dirty="0"/>
+          </a:p>
+          <a:p>
+            <a:r>
+              <a:rPr lang="en-US" dirty="0"/>
+              <a:t>If you run a study, a course, an intervention, or some other guided digital program, usually one page or one form is not enough. You need a process that continues over time.</a:t>
+            </a:r>
+          </a:p>
+          <a:p>
+            <a:endParaRPr lang="en-US" dirty="0"/>
+          </a:p>
+          <a:p>
+            <a:r>
+              <a:rPr lang="en-US" dirty="0"/>
+              <a:t>For example, you may want to guide people into the program, collect data at different moments, change what they see, randomize them into different conditions, and send follow-up steps later.</a:t>
+            </a:r>
+          </a:p>
+          <a:p>
+            <a:endParaRPr lang="en-US" dirty="0"/>
+          </a:p>
+          <a:p>
+            <a:r>
+              <a:rPr lang="en-US" dirty="0"/>
+              <a:t>This is possible in </a:t>
             </a:r>
             <a:r>
               <a:rPr lang="en-US" dirty="0" err="1"/>
@@ -959,27 +975,34 @@
             </a:r>
             <a:r>
               <a:rPr lang="en-US" dirty="0"/>
-              <a:t>, you’re not just creating content—you can build an entire digital program. That includes onboarding, structured assessments, reminders, and follow-up, all in one place instead of across different tools.</a:t>
-            </a:r>
-          </a:p>
-          <a:p>
-            <a:endParaRPr dirty="0"/>
+              <a:t>.</a:t>
+            </a:r>
+          </a:p>
+          <a:p>
+            <a:endParaRPr lang="en-US" dirty="0"/>
           </a:p>
           <a:p>
             <a:r>
               <a:rPr lang="en-US" dirty="0"/>
-              <a:t>Users then move through the program step by step. And along the way, the system can adapt—based on their role, their group, their language, or what they’ve already done.</a:t>
-            </a:r>
-          </a:p>
-          <a:p>
-            <a:endParaRPr dirty="0"/>
+              <a:t>You can set up baseline and follow-up sessions, plan repeated sessions, and control when and how often something should happen. This is useful both for research and for practical programs.</a:t>
+            </a:r>
+          </a:p>
+          <a:p>
+            <a:endParaRPr lang="en-US" dirty="0"/>
           </a:p>
           <a:p>
             <a:r>
               <a:rPr lang="en-US" dirty="0"/>
-              <a:t>So the real value isn’t just publishing content… it’s being able to run a process over time.</a:t>
-            </a:r>
-            <a:endParaRPr dirty="0"/>
+              <a:t>So the main point is simple: </a:t>
+            </a:r>
+            <a:r>
+              <a:rPr lang="en-US" dirty="0" err="1"/>
+              <a:t>SelfHelp</a:t>
+            </a:r>
+            <a:r>
+              <a:rPr lang="en-US" dirty="0"/>
+              <a:t> is not only for one single step. It can support a full process over time.</a:t>
+            </a:r>
           </a:p>
         </p:txBody>
       </p:sp>
@@ -1048,45 +1071,52 @@
           <a:lstStyle/>
           <a:p>
             <a:r>
-              <a:rPr dirty="0"/>
-              <a:t>Another important part of the story is how </a:t>
-            </a:r>
-            <a:r>
-              <a:rPr dirty="0" err="1"/>
+              <a:rPr lang="en-US" dirty="0"/>
+              <a:t>One important idea in </a:t>
+            </a:r>
+            <a:r>
+              <a:rPr lang="en-US" dirty="0" err="1"/>
               <a:t>SelfHelp</a:t>
             </a:r>
             <a:r>
-              <a:rPr dirty="0"/>
-              <a:t> grows.</a:t>
-            </a:r>
-          </a:p>
-          <a:p>
-            <a:endParaRPr dirty="0"/>
-          </a:p>
-          <a:p>
-            <a:r>
               <a:rPr lang="en-US" dirty="0"/>
-              <a:t>It expands through plugins. So instead of rebuilding the whole platform every time, you can just add new capabilities when you need them.</a:t>
-            </a:r>
-          </a:p>
-          <a:p>
-            <a:endParaRPr dirty="0"/>
+              <a:t> is that new functions are added through plugins.</a:t>
+            </a:r>
+          </a:p>
+          <a:p>
+            <a:endParaRPr lang="en-US" dirty="0"/>
           </a:p>
           <a:p>
             <a:r>
               <a:rPr lang="en-US" dirty="0"/>
-              <a:t>Some of these plugins work more in the background. For example, external authentication helps with institutional access. Lab.js brings browser-based experiments into the same system. R integration allows more advanced analysis. And custom formulas let you calculate scores and derived values directly inside the platform.</a:t>
-            </a:r>
-          </a:p>
-          <a:p>
-            <a:endParaRPr dirty="0"/>
+              <a:t>These are usually functions that are quite different from the core system.</a:t>
+            </a:r>
+          </a:p>
+          <a:p>
+            <a:endParaRPr lang="en-US" dirty="0"/>
           </a:p>
           <a:p>
             <a:r>
               <a:rPr lang="en-US" dirty="0"/>
-              <a:t>And then there are newer plugins that are much more visible to users. Those are the three I want to show you next.</a:t>
-            </a:r>
-            <a:endParaRPr dirty="0"/>
+              <a:t>This is useful for development, because it keeps the code cleaner and better organized. It also keeps an installation lighter. If a project does not need some features, they do not have to be included.</a:t>
+            </a:r>
+          </a:p>
+          <a:p>
+            <a:endParaRPr lang="en-US" dirty="0"/>
+          </a:p>
+          <a:p>
+            <a:r>
+              <a:rPr lang="en-US" dirty="0"/>
+              <a:t>In the next few slides, I would like to focus on 3 of these plugins: </a:t>
+            </a:r>
+            <a:r>
+              <a:rPr lang="en-US" dirty="0" err="1"/>
+              <a:t>SurveyJS</a:t>
+            </a:r>
+            <a:r>
+              <a:rPr lang="en-US" dirty="0"/>
+              <a:t>, LLM, and LLM Therapy Chat</a:t>
+            </a:r>
           </a:p>
         </p:txBody>
       </p:sp>
@@ -1156,54 +1186,7 @@
           <a:p>
             <a:r>
               <a:rPr lang="en-US" dirty="0"/>
-              <a:t>The first plugin that I want to present is </a:t>
-            </a:r>
-            <a:r>
-              <a:rPr dirty="0" err="1"/>
-              <a:t>SurveyJS</a:t>
-            </a:r>
-            <a:r>
-              <a:rPr lang="en-US" dirty="0"/>
-              <a:t>. That plugin</a:t>
-            </a:r>
-            <a:r>
-              <a:rPr dirty="0"/>
-              <a:t> is a good example of how </a:t>
-            </a:r>
-            <a:r>
-              <a:rPr dirty="0" err="1"/>
-              <a:t>SelfHelp</a:t>
-            </a:r>
-            <a:r>
-              <a:rPr dirty="0"/>
-              <a:t> has moved beyond simple forms.</a:t>
-            </a:r>
-          </a:p>
-          <a:p>
-            <a:endParaRPr dirty="0"/>
-          </a:p>
-          <a:p>
-            <a:r>
-              <a:rPr dirty="0"/>
-              <a:t>The key point is not only that surveys can be created. The key point is that they can be managed properly inside the platform. They can be versioned, scheduled, edited later, and connected to dashboards.</a:t>
-            </a:r>
-          </a:p>
-          <a:p>
-            <a:endParaRPr dirty="0"/>
-          </a:p>
-          <a:p>
-            <a:r>
-              <a:rPr lang="en-US" dirty="0"/>
-              <a:t>That makes a big difference for data quality, especially when you’re running repeated assessments over time. It also makes things more flexible, because responses aren’t limited to just text—you can include files or even voice recordings.</a:t>
-            </a:r>
-          </a:p>
-          <a:p>
-            <a:endParaRPr dirty="0"/>
-          </a:p>
-          <a:p>
-            <a:r>
-              <a:rPr lang="en-US" dirty="0"/>
-              <a:t>So overall, </a:t>
+              <a:t>The first plugin is </a:t>
             </a:r>
             <a:r>
               <a:rPr lang="en-US" dirty="0" err="1"/>
@@ -1211,17 +1194,53 @@
             </a:r>
             <a:r>
               <a:rPr lang="en-US" dirty="0"/>
-              <a:t> turns </a:t>
-            </a:r>
-            <a:r>
-              <a:rPr lang="en-US" dirty="0" err="1"/>
-              <a:t>SelfHelp</a:t>
-            </a:r>
+              <a:t>.</a:t>
+            </a:r>
+          </a:p>
+          <a:p>
+            <a:endParaRPr lang="en-US" dirty="0"/>
+          </a:p>
+          <a:p>
             <a:r>
               <a:rPr lang="en-US" dirty="0"/>
-              <a:t> into a much stronger environment for structured data collection over time.</a:t>
-            </a:r>
-            <a:endParaRPr dirty="0"/>
+              <a:t>Here the main idea is that we move from simple forms to real surveys that are part of a bigger process.</a:t>
+            </a:r>
+          </a:p>
+          <a:p>
+            <a:endParaRPr lang="en-US" dirty="0"/>
+          </a:p>
+          <a:p>
+            <a:r>
+              <a:rPr lang="en-US" dirty="0"/>
+              <a:t>So this is not only one page with some questions. Surveys can have different versions, can appear at planned times, can be changed later, and can be connected to dashboards. They can also be used in repeated studies over time.</a:t>
+            </a:r>
+          </a:p>
+          <a:p>
+            <a:endParaRPr lang="en-US" dirty="0"/>
+          </a:p>
+          <a:p>
+            <a:r>
+              <a:rPr lang="en-US" dirty="0"/>
+              <a:t>For example, you can define a baseline survey, later follow-up surveys, or diary-style surveys that appear again and again. You can also control things like once per user, once per schedule, timeout behavior, and edit mode. This is helpful when a survey should come back later, or when someone should continue or update an earlier answer.</a:t>
+            </a:r>
+          </a:p>
+          <a:p>
+            <a:endParaRPr lang="en-US" dirty="0"/>
+          </a:p>
+          <a:p>
+            <a:r>
+              <a:rPr lang="en-US" dirty="0"/>
+              <a:t>There are also practical features that are useful in real studies. Users can upload files, record voice, and continue later because of autosave. The system also stores timing information, like when a survey started, when it ended, how long it took, and which pages were used. So you get more than only the final answers.</a:t>
+            </a:r>
+          </a:p>
+          <a:p>
+            <a:endParaRPr lang="en-US" dirty="0"/>
+          </a:p>
+          <a:p>
+            <a:r>
+              <a:rPr lang="en-US" dirty="0"/>
+              <a:t>There is also support for dynamic values, dynamic replacement, dropdown values from other sources, dashboards, versioning, and safer handling of saving and navigation. So overall, the plugin is not only about asking questions. It is about managing survey-based data collection in a much more structured way.</a:t>
+            </a:r>
           </a:p>
         </p:txBody>
       </p:sp>
@@ -1291,7 +1310,7 @@
           <a:p>
             <a:r>
               <a:rPr lang="en-US" dirty="0"/>
-              <a:t>The next plugin is  the LLM plugin. I want to point out that this is not just a chatbot. It can be described better as a controlled, testable AI component.</a:t>
+              <a:t>The second plugin is the LLM plugin.</a:t>
             </a:r>
           </a:p>
           <a:p>
@@ -1300,7 +1319,7 @@
           <a:p>
             <a:r>
               <a:rPr lang="en-US" dirty="0"/>
-              <a:t>What that means is you can place a purpose-built assistant directly inside a page, with a clear role and a clear context.</a:t>
+              <a:t>I think most people here already know what an LLM is, so the interesting part is not the general idea of AI, but how we use it inside the system.</a:t>
             </a:r>
           </a:p>
           <a:p>
@@ -1309,7 +1328,7 @@
           <a:p>
             <a:r>
               <a:rPr lang="en-US" dirty="0"/>
-              <a:t>A big part of this is the prompt management system that comes with it. The prompts are the context that we send to the LLMs, they can be versioned, tested, and improved before they’re actually used in a real setting.</a:t>
+              <a:t>The important point is this: the AI does not only get the text that the user writes. It can also get extra information from the system.</a:t>
             </a:r>
           </a:p>
           <a:p>
@@ -1318,7 +1337,7 @@
           <a:p>
             <a:r>
               <a:rPr lang="en-US" dirty="0"/>
-              <a:t>It also supports different types of input—like text, files, images, or even speech.</a:t>
+              <a:t>This is where prompt and context become important.</a:t>
             </a:r>
           </a:p>
           <a:p>
@@ -1327,7 +1346,7 @@
           <a:p>
             <a:r>
               <a:rPr lang="en-US" dirty="0"/>
-              <a:t>And on the output side, it’s not limited to just chat. It can return structured data as well, which makes it much easier to integrate AI results back into the platform.</a:t>
+              <a:t>A prompt is the instruction we give to the AI. It tells the AI what kind of task it should do.</a:t>
             </a:r>
           </a:p>
           <a:p>
@@ -1336,7 +1355,133 @@
           <a:p>
             <a:r>
               <a:rPr lang="en-US" dirty="0"/>
-              <a:t>And importantly, everything can run on the university’s local LLM infrastructure—so the data stays within the university environment.</a:t>
+              <a:t>For example, we can tell it: “Explain this text in simple language for first-year students.”</a:t>
+            </a:r>
+          </a:p>
+          <a:p>
+            <a:endParaRPr lang="en-US" dirty="0"/>
+          </a:p>
+          <a:p>
+            <a:r>
+              <a:rPr lang="en-US" dirty="0"/>
+              <a:t>That is the prompt.</a:t>
+            </a:r>
+          </a:p>
+          <a:p>
+            <a:endParaRPr lang="en-US" dirty="0"/>
+          </a:p>
+          <a:p>
+            <a:r>
+              <a:rPr lang="en-US" dirty="0"/>
+              <a:t>But then we also give context.</a:t>
+            </a:r>
+          </a:p>
+          <a:p>
+            <a:endParaRPr lang="en-US" dirty="0"/>
+          </a:p>
+          <a:p>
+            <a:r>
+              <a:rPr lang="en-US" dirty="0"/>
+              <a:t>Context means extra information around the task. For example, we can tell the AI who the user is, what happened before, what the current step is, or what data was already entered earlier.</a:t>
+            </a:r>
+          </a:p>
+          <a:p>
+            <a:endParaRPr lang="en-US" dirty="0"/>
+          </a:p>
+          <a:p>
+            <a:r>
+              <a:rPr lang="en-US" dirty="0"/>
+              <a:t>So the AI does not only see one sentence. It sees the situation around that sentence.</a:t>
+            </a:r>
+          </a:p>
+          <a:p>
+            <a:endParaRPr lang="en-US" dirty="0"/>
+          </a:p>
+          <a:p>
+            <a:r>
+              <a:rPr lang="en-US" dirty="0"/>
+              <a:t>And this changes the result.</a:t>
+            </a:r>
+          </a:p>
+          <a:p>
+            <a:endParaRPr lang="en-US" dirty="0"/>
+          </a:p>
+          <a:p>
+            <a:r>
+              <a:rPr lang="en-US" dirty="0"/>
+              <a:t>For example, imagine a user writes: “I do not understand this.”</a:t>
+            </a:r>
+          </a:p>
+          <a:p>
+            <a:br>
+              <a:rPr lang="en-US" dirty="0"/>
+            </a:br>
+            <a:r>
+              <a:rPr lang="en-US" dirty="0"/>
+              <a:t>If the AI only sees this one sentence, the answer may stay general.</a:t>
+            </a:r>
+          </a:p>
+          <a:p>
+            <a:br>
+              <a:rPr lang="en-US" dirty="0"/>
+            </a:br>
+            <a:r>
+              <a:rPr lang="en-US" dirty="0"/>
+              <a:t>But if the system also sends the previous task, the user role, and the page context, then the AI can answer in a much more useful way.</a:t>
+            </a:r>
+          </a:p>
+          <a:p>
+            <a:endParaRPr lang="en-US" dirty="0"/>
+          </a:p>
+          <a:p>
+            <a:r>
+              <a:rPr lang="en-US" dirty="0"/>
+              <a:t>So in simple words:</a:t>
+            </a:r>
+          </a:p>
+          <a:p>
+            <a:br>
+              <a:rPr lang="en-US" dirty="0"/>
+            </a:br>
+            <a:r>
+              <a:rPr lang="en-US" dirty="0"/>
+              <a:t>the prompt says what to do,</a:t>
+            </a:r>
+          </a:p>
+          <a:p>
+            <a:br>
+              <a:rPr lang="en-US" dirty="0"/>
+            </a:br>
+            <a:r>
+              <a:rPr lang="en-US" dirty="0"/>
+              <a:t>the context says what the situation is,</a:t>
+            </a:r>
+          </a:p>
+          <a:p>
+            <a:br>
+              <a:rPr lang="en-US" dirty="0"/>
+            </a:br>
+            <a:r>
+              <a:rPr lang="en-US" dirty="0"/>
+              <a:t>and together they shape the result.</a:t>
+            </a:r>
+          </a:p>
+          <a:p>
+            <a:endParaRPr lang="en-US" dirty="0"/>
+          </a:p>
+          <a:p>
+            <a:r>
+              <a:rPr lang="en-US" dirty="0"/>
+              <a:t>In our system, this is not random. We can test prompts, compare versions, replay examples, and evaluate what works better before using it in practice.</a:t>
+            </a:r>
+          </a:p>
+          <a:p>
+            <a:endParaRPr lang="en-US" dirty="0"/>
+          </a:p>
+          <a:p>
+            <a:r>
+              <a:rPr lang="en-US" dirty="0"/>
+              <a:t>And now we also have memory-related functions. This means the system can keep selected information over time and use it again later, based on rules. So the AI part becomes more structured, more useful, and also more controllable.</a:t>
             </a:r>
           </a:p>
         </p:txBody>
@@ -1407,7 +1552,7 @@
           <a:p>
             <a:r>
               <a:rPr lang="en-US" dirty="0"/>
-              <a:t>The last plugin is the therapy chat plugin.</a:t>
+              <a:t>The third plugin is the therapy chat.</a:t>
             </a:r>
           </a:p>
           <a:p>
@@ -1416,7 +1561,7 @@
           <a:p>
             <a:r>
               <a:rPr lang="en-US" dirty="0"/>
-              <a:t>The key idea here is supervised communication. A user can interact with AI, but therapists are still actively involved through their own dashboard.</a:t>
+              <a:t>This plugin combines AI-supported communication with human supervision in one shared framework.</a:t>
             </a:r>
           </a:p>
           <a:p>
@@ -1425,7 +1570,7 @@
           <a:p>
             <a:r>
               <a:rPr lang="en-US" dirty="0"/>
-              <a:t>They can review conversations, step in when needed, write notes, create drafts, and manage risk.</a:t>
+              <a:t>From the user side, it is very simple. The user has a chat interface. They always know whether they are interacting with AI or with a human, and this is of course very important.</a:t>
             </a:r>
           </a:p>
           <a:p>
@@ -1434,7 +1579,7 @@
           <a:p>
             <a:r>
               <a:rPr lang="en-US" dirty="0"/>
-              <a:t>Another important point is that this setup can also run without AI. So you can use the same framework for both AI-assisted and fully human communication.</a:t>
+              <a:t>From the professional side, there is a therapist dashboard. There, therapists can monitor conversations, receive alerts, read summaries, write notes, create drafts, and step in directly when needed.</a:t>
             </a:r>
           </a:p>
           <a:p>
@@ -1443,7 +1588,16 @@
           <a:p>
             <a:r>
               <a:rPr lang="en-US" dirty="0"/>
-              <a:t>And that’s what makes it interesting—not just for service delivery, but also for research, because you can compare different communication approaches within the same system.</a:t>
+              <a:t>This is useful not only for service delivery, but also for research, because the same framework can also run in human-only mode. That means you can compare different communication settings in a controlled way.</a:t>
+            </a:r>
+          </a:p>
+          <a:p>
+            <a:endParaRPr lang="en-US" dirty="0"/>
+          </a:p>
+          <a:p>
+            <a:r>
+              <a:rPr lang="en-US" dirty="0"/>
+              <a:t>There are also safety-related functions. For example, risk detection, alerts, pausing conversations, switching to human-only handling, and notification workflows. So again, the point is not just chat. The point is structured communication, supervision, and control.</a:t>
             </a:r>
           </a:p>
         </p:txBody>
@@ -1514,7 +1668,7 @@
           <a:p>
             <a:r>
               <a:rPr lang="en-US" dirty="0"/>
-              <a:t>Another crucial part of the system is the mobile app. It is important because digital programs don’t just live on a desktop.</a:t>
+              <a:t>Another important part is the mobile application.</a:t>
             </a:r>
           </a:p>
           <a:p>
@@ -1523,15 +1677,16 @@
           <a:p>
             <a:r>
               <a:rPr lang="en-US" dirty="0"/>
-              <a:t>With </a:t>
-            </a:r>
-            <a:r>
-              <a:rPr lang="en-US" dirty="0" err="1"/>
-              <a:t>SelfHelp</a:t>
-            </a:r>
+              <a:t>This matters because many digital programs do not work well if they only live on the desktop. In real life, people answer, react, and engage during the day, while they are moving, waiting, or just living normal life.</a:t>
+            </a:r>
+          </a:p>
+          <a:p>
+            <a:endParaRPr lang="en-US" dirty="0"/>
+          </a:p>
+          <a:p>
             <a:r>
               <a:rPr lang="en-US" dirty="0"/>
-              <a:t>, the same program logic continues on mobile—so it becomes part of everyday use, not just something you access occasionally on a computer.</a:t>
+              <a:t>So with the mobile app, the same program logic can continue on the phone.</a:t>
             </a:r>
           </a:p>
           <a:p>
@@ -1540,7 +1695,7 @@
           <a:p>
             <a:r>
               <a:rPr lang="en-US" dirty="0"/>
-              <a:t>All the features that are supported on the web part are already supported on the mobile app too. Like: surveys, AI chat, therapy chat, notifications, and even camera and microphone input.</a:t>
+              <a:t>Users can answer surveys, use AI chat or therapy chat, receive push notifications, and also use camera, microphone, and voice input.</a:t>
             </a:r>
           </a:p>
           <a:p>
@@ -1549,16 +1704,7 @@
           <a:p>
             <a:r>
               <a:rPr lang="en-US" dirty="0"/>
-              <a:t>Using a mobile app for your research means in practice, that people (subjects) can interact with the program when it fits their day. They can respond, upload something, or continue a conversation—wherever they are.</a:t>
-            </a:r>
-          </a:p>
-          <a:p>
-            <a:endParaRPr lang="en-US" dirty="0"/>
-          </a:p>
-          <a:p>
-            <a:r>
-              <a:rPr lang="en-US" dirty="0"/>
-              <a:t>So instead of being tied to one place, the program stays with the user across different situations.</a:t>
+              <a:t>This makes the system much more present in daily life. It is no longer something that people only open once on a laptop. It can become part of an ongoing process.</a:t>
             </a:r>
           </a:p>
         </p:txBody>
@@ -1728,7 +1874,7 @@
           <a:p>
             <a:fld id="{1D8BD707-D9CF-40AE-B4C6-C98DA3205C09}" type="datetimeFigureOut">
               <a:rPr lang="en-US"/>
-              <a:t>25-Mar-26</a:t>
+              <a:t>26-Mar-26</a:t>
             </a:fld>
             <a:endParaRPr lang="en-US"/>
           </a:p>
@@ -1899,7 +2045,7 @@
           <a:p>
             <a:fld id="{1D8BD707-D9CF-40AE-B4C6-C98DA3205C09}" type="datetimeFigureOut">
               <a:rPr lang="en-US"/>
-              <a:t>25-Mar-26</a:t>
+              <a:t>26-Mar-26</a:t>
             </a:fld>
             <a:endParaRPr lang="en-US"/>
           </a:p>
@@ -2119,7 +2265,7 @@
           <a:p>
             <a:fld id="{1D8BD707-D9CF-40AE-B4C6-C98DA3205C09}" type="datetimeFigureOut">
               <a:rPr lang="en-US"/>
-              <a:t>25-Mar-26</a:t>
+              <a:t>26-Mar-26</a:t>
             </a:fld>
             <a:endParaRPr lang="en-US"/>
           </a:p>
@@ -2267,7 +2413,7 @@
           <a:p>
             <a:fld id="{1D8BD707-D9CF-40AE-B4C6-C98DA3205C09}" type="datetimeFigureOut">
               <a:rPr lang="en-US"/>
-              <a:t>25-Mar-26</a:t>
+              <a:t>26-Mar-26</a:t>
             </a:fld>
             <a:endParaRPr lang="en-US"/>
           </a:p>
@@ -2386,7 +2532,7 @@
           <a:p>
             <a:fld id="{1D8BD707-D9CF-40AE-B4C6-C98DA3205C09}" type="datetimeFigureOut">
               <a:rPr lang="en-US"/>
-              <a:t>25-Mar-26</a:t>
+              <a:t>26-Mar-26</a:t>
             </a:fld>
             <a:endParaRPr lang="en-US"/>
           </a:p>
@@ -2605,7 +2751,7 @@
           <a:p>
             <a:fld id="{1D8BD707-D9CF-40AE-B4C6-C98DA3205C09}" type="datetimeFigureOut">
               <a:rPr lang="en-US"/>
-              <a:t>25-Mar-26</a:t>
+              <a:t>26-Mar-26</a:t>
             </a:fld>
             <a:endParaRPr lang="en-US"/>
           </a:p>

</xml_diff>